<commit_message>
work on array slides
</commit_message>
<xml_diff>
--- a/topic06-arrays/unit-1/talk-1-intro-to-arrays/a-arrays.pptx
+++ b/topic06-arrays/unit-1/talk-1-intro-to-arrays/a-arrays.pptx
@@ -251,7 +251,7 @@
           <a:p>
             <a:fld id="{58C3D141-1E1C-433C-AD3A-CD56CBBB4F9F}" type="datetimeFigureOut">
               <a:rPr lang="en-IE" smtClean="0"/>
-              <a:t>18/10/2025</a:t>
+              <a:t>19/10/2025</a:t>
             </a:fld>
             <a:endParaRPr lang="en-IE"/>
           </a:p>
@@ -7147,7 +7147,7 @@
             <a:fld id="{1D8BD707-D9CF-40AE-B4C6-C98DA3205C09}" type="datetimeFigureOut">
               <a:rPr lang="en-US" smtClean="0"/>
               <a:pPr/>
-              <a:t>10/18/25</a:t>
+              <a:t>10/19/25</a:t>
             </a:fld>
             <a:endParaRPr lang="en-US"/>
           </a:p>
@@ -7319,7 +7319,7 @@
             <a:fld id="{1D8BD707-D9CF-40AE-B4C6-C98DA3205C09}" type="datetimeFigureOut">
               <a:rPr lang="en-US" smtClean="0"/>
               <a:pPr/>
-              <a:t>10/18/25</a:t>
+              <a:t>10/19/25</a:t>
             </a:fld>
             <a:endParaRPr lang="en-US"/>
           </a:p>
@@ -7501,7 +7501,7 @@
             <a:fld id="{1D8BD707-D9CF-40AE-B4C6-C98DA3205C09}" type="datetimeFigureOut">
               <a:rPr lang="en-US" smtClean="0"/>
               <a:pPr/>
-              <a:t>10/18/25</a:t>
+              <a:t>10/19/25</a:t>
             </a:fld>
             <a:endParaRPr lang="en-US"/>
           </a:p>
@@ -8140,7 +8140,7 @@
             <a:fld id="{1D8BD707-D9CF-40AE-B4C6-C98DA3205C09}" type="datetimeFigureOut">
               <a:rPr lang="en-US" smtClean="0"/>
               <a:pPr/>
-              <a:t>10/18/25</a:t>
+              <a:t>10/19/25</a:t>
             </a:fld>
             <a:endParaRPr lang="en-US"/>
           </a:p>
@@ -8558,7 +8558,7 @@
             <a:fld id="{1D8BD707-D9CF-40AE-B4C6-C98DA3205C09}" type="datetimeFigureOut">
               <a:rPr lang="en-US" smtClean="0"/>
               <a:pPr/>
-              <a:t>10/18/25</a:t>
+              <a:t>10/19/25</a:t>
             </a:fld>
             <a:endParaRPr lang="en-US"/>
           </a:p>
@@ -8859,7 +8859,7 @@
             <a:fld id="{1D8BD707-D9CF-40AE-B4C6-C98DA3205C09}" type="datetimeFigureOut">
               <a:rPr lang="en-US" smtClean="0"/>
               <a:pPr/>
-              <a:t>10/18/25</a:t>
+              <a:t>10/19/25</a:t>
             </a:fld>
             <a:endParaRPr lang="en-US"/>
           </a:p>
@@ -9448,7 +9448,7 @@
             <a:fld id="{1D8BD707-D9CF-40AE-B4C6-C98DA3205C09}" type="datetimeFigureOut">
               <a:rPr lang="en-US" smtClean="0"/>
               <a:pPr/>
-              <a:t>10/18/25</a:t>
+              <a:t>10/19/25</a:t>
             </a:fld>
             <a:endParaRPr lang="en-US"/>
           </a:p>
@@ -9696,7 +9696,7 @@
             <a:fld id="{1D8BD707-D9CF-40AE-B4C6-C98DA3205C09}" type="datetimeFigureOut">
               <a:rPr lang="en-US" smtClean="0"/>
               <a:pPr/>
-              <a:t>10/18/25</a:t>
+              <a:t>10/19/25</a:t>
             </a:fld>
             <a:endParaRPr lang="en-US"/>
           </a:p>
@@ -9951,7 +9951,7 @@
             <a:fld id="{1D8BD707-D9CF-40AE-B4C6-C98DA3205C09}" type="datetimeFigureOut">
               <a:rPr lang="en-US" smtClean="0"/>
               <a:pPr/>
-              <a:t>10/18/25</a:t>
+              <a:t>10/19/25</a:t>
             </a:fld>
             <a:endParaRPr lang="en-US"/>
           </a:p>
@@ -10230,7 +10230,7 @@
             <a:fld id="{1D8BD707-D9CF-40AE-B4C6-C98DA3205C09}" type="datetimeFigureOut">
               <a:rPr lang="en-US" smtClean="0"/>
               <a:pPr/>
-              <a:t>10/18/25</a:t>
+              <a:t>10/19/25</a:t>
             </a:fld>
             <a:endParaRPr lang="en-US"/>
           </a:p>
@@ -10489,7 +10489,7 @@
             <a:fld id="{1D8BD707-D9CF-40AE-B4C6-C98DA3205C09}" type="datetimeFigureOut">
               <a:rPr lang="en-US" smtClean="0"/>
               <a:pPr/>
-              <a:t>10/18/25</a:t>
+              <a:t>10/19/25</a:t>
             </a:fld>
             <a:endParaRPr lang="en-US"/>
           </a:p>
@@ -10709,7 +10709,7 @@
             <a:fld id="{1D8BD707-D9CF-40AE-B4C6-C98DA3205C09}" type="datetimeFigureOut">
               <a:rPr lang="en-US" smtClean="0"/>
               <a:pPr/>
-              <a:t>10/18/25</a:t>
+              <a:t>10/19/25</a:t>
             </a:fld>
             <a:endParaRPr lang="en-US"/>
           </a:p>
@@ -32759,9 +32759,15 @@
       </p:sp>
       <p:pic>
         <p:nvPicPr>
-          <p:cNvPr id="3074" name="Picture 2" descr="Image result for questions"/>
+          <p:cNvPr id="3" name="Picture 2" descr="A green question mark in a circle&#10;&#10;AI-generated content may be incorrect.">
+            <a:extLst>
+              <a:ext uri="{FF2B5EF4-FFF2-40B4-BE49-F238E27FC236}">
+                <a16:creationId xmlns:a16="http://schemas.microsoft.com/office/drawing/2014/main" id="{7208605A-4105-7835-1D2F-9A2483838AA1}"/>
+              </a:ext>
+            </a:extLst>
+          </p:cNvPr>
           <p:cNvPicPr>
-            <a:picLocks noChangeAspect="1" noChangeArrowheads="1"/>
+            <a:picLocks noChangeAspect="1"/>
           </p:cNvPicPr>
           <p:nvPr/>
         </p:nvPicPr>
@@ -32773,29 +32779,18 @@
               </a:ext>
             </a:extLst>
           </a:blip>
-          <a:srcRect/>
           <a:stretch>
             <a:fillRect/>
           </a:stretch>
         </p:blipFill>
-        <p:spPr bwMode="auto">
+        <p:spPr>
           <a:xfrm>
-            <a:off x="3810000" y="2057401"/>
-            <a:ext cx="4343400" cy="3509469"/>
+            <a:off x="2971800" y="1325562"/>
+            <a:ext cx="5257800" cy="5257800"/>
           </a:xfrm>
           <a:prstGeom prst="rect">
             <a:avLst/>
           </a:prstGeom>
-          <a:noFill/>
-          <a:extLst>
-            <a:ext uri="{909E8E84-426E-40DD-AFC4-6F175D3DCCD1}">
-              <a14:hiddenFill xmlns:a14="http://schemas.microsoft.com/office/drawing/2010/main">
-                <a:solidFill>
-                  <a:srgbClr val="FFFFFF"/>
-                </a:solidFill>
-              </a14:hiddenFill>
-            </a:ext>
-          </a:extLst>
         </p:spPr>
       </p:pic>
     </p:spTree>

</xml_diff>